<commit_message>
Add sourced public HVAC work orders to Langflow prototype
</commit_message>
<xml_diff>
--- a/docs/02-pitch-deck.pptx
+++ b/docs/02-pitch-deck.pptx
@@ -2,25 +2,25 @@
 <file path=ppt/presentation.xml><?xml version="1.0" encoding="utf-8"?>
 <p:presentation xmlns:p="http://schemas.openxmlformats.org/presentationml/2006/main">
   <p:sldMasterIdLst>
-    <p:sldMasterId xmlns:r="http://schemas.openxmlformats.org/officeDocument/2006/relationships" id="2147483648" r:id="Reff11f76dd7947e1"/>
+    <p:sldMasterId xmlns:r="http://schemas.openxmlformats.org/officeDocument/2006/relationships" id="2147483648" r:id="R5a6664a548b744ba"/>
   </p:sldMasterIdLst>
   <p:notesMasterIdLst>
-    <p:notesMasterId xmlns:r="http://schemas.openxmlformats.org/officeDocument/2006/relationships" r:id="Rbecfb535fde742dc"/>
+    <p:notesMasterId xmlns:r="http://schemas.openxmlformats.org/officeDocument/2006/relationships" r:id="R037c8194d7b44976"/>
   </p:notesMasterIdLst>
   <p:sldIdLst>
-    <p:sldId xmlns:r="http://schemas.openxmlformats.org/officeDocument/2006/relationships" id="256" r:id="R37de2016d48748dc"/>
-    <p:sldId xmlns:r="http://schemas.openxmlformats.org/officeDocument/2006/relationships" id="257" r:id="R2daaee4781474771"/>
-    <p:sldId xmlns:r="http://schemas.openxmlformats.org/officeDocument/2006/relationships" id="258" r:id="Rc9b713c274e34d7e"/>
-    <p:sldId xmlns:r="http://schemas.openxmlformats.org/officeDocument/2006/relationships" id="259" r:id="Rb7e24b9ee1d849a9"/>
-    <p:sldId xmlns:r="http://schemas.openxmlformats.org/officeDocument/2006/relationships" id="260" r:id="R84abe8d08bca47d7"/>
-    <p:sldId xmlns:r="http://schemas.openxmlformats.org/officeDocument/2006/relationships" id="261" r:id="R37b6b637e1a2472d"/>
-    <p:sldId xmlns:r="http://schemas.openxmlformats.org/officeDocument/2006/relationships" id="262" r:id="R558e69eb420c4b47"/>
-    <p:sldId xmlns:r="http://schemas.openxmlformats.org/officeDocument/2006/relationships" id="263" r:id="R71cb7dfa31b446bb"/>
-    <p:sldId xmlns:r="http://schemas.openxmlformats.org/officeDocument/2006/relationships" id="264" r:id="R6c30bbe1c3cd4363"/>
-    <p:sldId xmlns:r="http://schemas.openxmlformats.org/officeDocument/2006/relationships" id="265" r:id="R0e8cd8cd7f5f4d55"/>
-    <p:sldId xmlns:r="http://schemas.openxmlformats.org/officeDocument/2006/relationships" id="266" r:id="Rf954f5b5b1f24bf7"/>
-    <p:sldId xmlns:r="http://schemas.openxmlformats.org/officeDocument/2006/relationships" id="267" r:id="R824ebc254db14e1b"/>
-    <p:sldId xmlns:r="http://schemas.openxmlformats.org/officeDocument/2006/relationships" id="268" r:id="Rc91e1610fff940aa"/>
+    <p:sldId xmlns:r="http://schemas.openxmlformats.org/officeDocument/2006/relationships" id="256" r:id="R0f227fb191494a46"/>
+    <p:sldId xmlns:r="http://schemas.openxmlformats.org/officeDocument/2006/relationships" id="257" r:id="R70d35a503e174b9f"/>
+    <p:sldId xmlns:r="http://schemas.openxmlformats.org/officeDocument/2006/relationships" id="258" r:id="R9d0b14e333954491"/>
+    <p:sldId xmlns:r="http://schemas.openxmlformats.org/officeDocument/2006/relationships" id="259" r:id="Rd1498e6a4b544620"/>
+    <p:sldId xmlns:r="http://schemas.openxmlformats.org/officeDocument/2006/relationships" id="260" r:id="Rea85bcba66a94ce0"/>
+    <p:sldId xmlns:r="http://schemas.openxmlformats.org/officeDocument/2006/relationships" id="261" r:id="R26017eb4185b48a9"/>
+    <p:sldId xmlns:r="http://schemas.openxmlformats.org/officeDocument/2006/relationships" id="262" r:id="R3a99e520cc1a40a7"/>
+    <p:sldId xmlns:r="http://schemas.openxmlformats.org/officeDocument/2006/relationships" id="263" r:id="Rb5959dccf35a47d6"/>
+    <p:sldId xmlns:r="http://schemas.openxmlformats.org/officeDocument/2006/relationships" id="264" r:id="R1936cc9b8a0b4b68"/>
+    <p:sldId xmlns:r="http://schemas.openxmlformats.org/officeDocument/2006/relationships" id="265" r:id="Rf157bd6478094d82"/>
+    <p:sldId xmlns:r="http://schemas.openxmlformats.org/officeDocument/2006/relationships" id="266" r:id="Rab72790785484cb7"/>
+    <p:sldId xmlns:r="http://schemas.openxmlformats.org/officeDocument/2006/relationships" id="267" r:id="Rd3cd91d863274a8a"/>
+    <p:sldId xmlns:r="http://schemas.openxmlformats.org/officeDocument/2006/relationships" id="268" r:id="R1902708641454a2a"/>
   </p:sldIdLst>
   <p:sldSz cx="12192000" cy="6858000"/>
   <p:notesSz cx="6858000" cy="9144000"/>
@@ -707,7 +707,7 @@
           <a:lstStyle xmlns:a="http://schemas.openxmlformats.org/drawingml/2006/main"/>
           <a:p xmlns:a="http://schemas.openxmlformats.org/drawingml/2006/main">
             <a:r>
-              <a:t/>
+              <a:t>NYC Parks AMPS work orders, published by NYC Open Data: https://data.cityofnewyork.us/d/8sdw-8vja . Selected public records 2791739, 2792582, 2792861. Retrieved 28 September 2026 Jakarta. This is genuine public operational metadata, not a customer pilot or proof of billability. Snapshot and exact query: data/public/nyc-parks-work-orders.json.</a:t>
             </a:r>
             <a:endParaRPr/>
           </a:p>
@@ -1668,8 +1668,8 @@
   </p:cSld>
   <p:clrMap bg1="lt1" tx1="dk1" bg2="lt2" tx2="dk2" accent1="accent1" accent2="accent2" accent3="accent3" accent4="accent4" accent5="accent5" accent6="accent6" hlink="hlink" folHlink="folHlink"/>
   <p:sldLayoutIdLst>
-    <p:sldLayoutId xmlns:r="http://schemas.openxmlformats.org/officeDocument/2006/relationships" id="2147483649" r:id="Rbdc1eab41fe449f9"/>
-    <p:sldLayoutId xmlns:r="http://schemas.openxmlformats.org/officeDocument/2006/relationships" id="2147483650" r:id="Reecfccac53a64739"/>
+    <p:sldLayoutId xmlns:r="http://schemas.openxmlformats.org/officeDocument/2006/relationships" id="2147483649" r:id="Rcffedb5894854f78"/>
+    <p:sldLayoutId xmlns:r="http://schemas.openxmlformats.org/officeDocument/2006/relationships" id="2147483650" r:id="Rdbc3bdaa412c4bdf"/>
   </p:sldLayoutIdLst>
   <p:hf sldNum="0" hdr="0" ftr="0" dt="0"/>
   <p:txStyles>
@@ -6710,7 +6710,7 @@
                 <a:ea typeface="Arial"/>
                 <a:cs typeface="Arial"/>
               </a:rPr>
-              <a:t>Synthetic HVAC case + rule-based browser prototype</a:t>
+              <a:t>3 public HVAC records + synthetic browser demo</a:t>
             </a:r>
             <a:endParaRPr sz="980"/>
           </a:p>
@@ -7100,7 +7100,7 @@
         </p:spPr>
         <p:txBody>
           <a:bodyPr xmlns:a="http://schemas.openxmlformats.org/drawingml/2006/main" wrap="square" lIns="0" tIns="0" rIns="0" bIns="0" anchor="ctr">
-            <a:normAutofit/>
+            <a:normAutofit fontScale="97038"/>
           </a:bodyPr>
           <a:lstStyle xmlns:a="http://schemas.openxmlformats.org/drawingml/2006/main"/>
           <a:p xmlns:a="http://schemas.openxmlformats.org/drawingml/2006/main">
@@ -7116,7 +7116,7 @@
                 <a:ea typeface="Arial"/>
                 <a:cs typeface="Arial"/>
               </a:rPr>
-              <a:t>Vertical sequence: HVAC -&gt; CCTV / low-voltage -&gt; IT/network field support -&gt; building/electrical maintenance.</a:t>
+              <a:t>Source: NYC Parks AMPS work orders 2791739, 2792582, 2792861. Public records do not include billing proof.</a:t>
             </a:r>
             <a:endParaRPr sz="950"/>
           </a:p>
@@ -13809,7 +13809,7 @@
         </p:spPr>
         <p:txBody>
           <a:bodyPr xmlns:a="http://schemas.openxmlformats.org/drawingml/2006/main" wrap="square" lIns="0" tIns="0" rIns="0" bIns="0" anchor="ctr">
-            <a:normAutofit/>
+            <a:normAutofit fontScale="100000"/>
           </a:bodyPr>
           <a:lstStyle xmlns:a="http://schemas.openxmlformats.org/drawingml/2006/main"/>
           <a:p xmlns:a="http://schemas.openxmlformats.org/drawingml/2006/main">
@@ -13825,7 +13825,7 @@
                 <a:ea typeface="Arial"/>
                 <a:cs typeface="Arial"/>
               </a:rPr>
-              <a:t>The demo does not fake evidence. It resolves gaps, re-validates, then asks a human to confirm readiness.</a:t>
+              <a:t>Synthetic evidence is labelled. Missing items stay blocked until a person reviews the pack.</a:t>
             </a:r>
             <a:endParaRPr sz="1300"/>
           </a:p>
@@ -15184,7 +15184,7 @@
           <p:nvPr/>
         </p:nvPicPr>
         <p:blipFill>
-          <a:blip xmlns:r="http://schemas.openxmlformats.org/officeDocument/2006/relationships" xmlns:a="http://schemas.openxmlformats.org/drawingml/2006/main" r:embed="Rfac5234366dc49bd"/>
+          <a:blip xmlns:r="http://schemas.openxmlformats.org/officeDocument/2006/relationships" xmlns:a="http://schemas.openxmlformats.org/drawingml/2006/main" r:embed="Rb076eb07c72d4ae6"/>
           <a:stretch xmlns:a="http://schemas.openxmlformats.org/drawingml/2006/main">
             <a:fillRect l="0" t="0" r="0" b="0"/>
           </a:stretch>
@@ -15260,7 +15260,7 @@
         </p:spPr>
         <p:txBody>
           <a:bodyPr xmlns:a="http://schemas.openxmlformats.org/drawingml/2006/main" wrap="square" lIns="0" tIns="0" rIns="0" bIns="0" anchor="ctr">
-            <a:normAutofit/>
+            <a:normAutofit fontScale="100000"/>
           </a:bodyPr>
           <a:lstStyle xmlns:a="http://schemas.openxmlformats.org/drawingml/2006/main"/>
           <a:p xmlns:a="http://schemas.openxmlformats.org/drawingml/2006/main">
@@ -15276,7 +15276,7 @@
                 <a:ea typeface="Arial"/>
                 <a:cs typeface="Arial"/>
               </a:rPr>
-              <a:t>IBM Bob: conversation + tool selection</a:t>
+              <a:t>IBM Bob: MCP connection confirmed</a:t>
             </a:r>
             <a:endParaRPr sz="950"/>
           </a:p>
@@ -15596,7 +15596,7 @@
         </p:spPr>
         <p:txBody>
           <a:bodyPr xmlns:a="http://schemas.openxmlformats.org/drawingml/2006/main" wrap="square" lIns="0" tIns="0" rIns="0" bIns="0" anchor="t">
-            <a:normAutofit/>
+            <a:normAutofit fontScale="100000"/>
           </a:bodyPr>
           <a:lstStyle xmlns:a="http://schemas.openxmlformats.org/drawingml/2006/main"/>
           <a:p xmlns:a="http://schemas.openxmlformats.org/drawingml/2006/main">
@@ -15612,7 +15612,7 @@
                 <a:ea typeface="Arial"/>
                 <a:cs typeface="Arial"/>
               </a:rPr>
-              <a:t>Bob asks. MCP routes. Langflow executes. The result stays structured.</a:t>
+              <a:t>Langflow MCP tools are connected. Bob calls await verification.</a:t>
             </a:r>
             <a:endParaRPr sz="2700"/>
           </a:p>
@@ -15976,7 +15976,7 @@
         </p:spPr>
         <p:txBody>
           <a:bodyPr xmlns:a="http://schemas.openxmlformats.org/drawingml/2006/main" wrap="square" lIns="0" tIns="0" rIns="0" bIns="0" anchor="ctr">
-            <a:normAutofit/>
+            <a:normAutofit fontScale="100000"/>
           </a:bodyPr>
           <a:lstStyle xmlns:a="http://schemas.openxmlformats.org/drawingml/2006/main"/>
           <a:p xmlns:a="http://schemas.openxmlformats.org/drawingml/2006/main">
@@ -15992,7 +15992,7 @@
                 <a:ea typeface="Arial"/>
                 <a:cs typeface="Arial"/>
               </a:rPr>
-              <a:t>Selects validate/readiness tools</a:t>
+              <a:t>MCP connection confirmed; tool call unverified</a:t>
             </a:r>
             <a:endParaRPr sz="1200"/>
           </a:p>
@@ -16404,7 +16404,7 @@
         </p:spPr>
         <p:txBody>
           <a:bodyPr xmlns:a="http://schemas.openxmlformats.org/drawingml/2006/main" wrap="square" lIns="0" tIns="0" rIns="0" bIns="0" anchor="ctr">
-            <a:normAutofit/>
+            <a:normAutofit fontScale="100000"/>
           </a:bodyPr>
           <a:lstStyle xmlns:a="http://schemas.openxmlformats.org/drawingml/2006/main"/>
           <a:p xmlns:a="http://schemas.openxmlformats.org/drawingml/2006/main">
@@ -16420,7 +16420,7 @@
                 <a:ea typeface="Arial"/>
                 <a:cs typeface="Arial"/>
               </a:rPr>
-              <a:t>retrieve -&gt; reason -&gt; rules -&gt; output</a:t>
+              <a:t>Source fields -&gt; transparent rules -&gt; JSON</a:t>
             </a:r>
             <a:endParaRPr sz="1200"/>
           </a:p>
@@ -16618,7 +16618,7 @@
         </p:spPr>
         <p:txBody>
           <a:bodyPr xmlns:a="http://schemas.openxmlformats.org/drawingml/2006/main" wrap="square" lIns="0" tIns="0" rIns="0" bIns="0" anchor="ctr">
-            <a:normAutofit/>
+            <a:normAutofit fontScale="100000"/>
           </a:bodyPr>
           <a:lstStyle xmlns:a="http://schemas.openxmlformats.org/drawingml/2006/main"/>
           <a:p xmlns:a="http://schemas.openxmlformats.org/drawingml/2006/main">
@@ -16634,7 +16634,7 @@
                 <a:ea typeface="Arial"/>
                 <a:cs typeface="Arial"/>
               </a:rPr>
-              <a:t>Explains blockers + asks approval</a:t>
+              <a:t>Bob tool response still unverified</a:t>
             </a:r>
             <a:endParaRPr sz="1200"/>
           </a:p>

</xml_diff>

<commit_message>
Finalize Stage 1 submission evidence and public demo
</commit_message>
<xml_diff>
--- a/docs/02-pitch-deck.pptx
+++ b/docs/02-pitch-deck.pptx
@@ -2,25 +2,25 @@
 <file path=ppt/presentation.xml><?xml version="1.0" encoding="utf-8"?>
 <p:presentation xmlns:p="http://schemas.openxmlformats.org/presentationml/2006/main">
   <p:sldMasterIdLst>
-    <p:sldMasterId xmlns:r="http://schemas.openxmlformats.org/officeDocument/2006/relationships" id="2147483648" r:id="R5a6664a548b744ba"/>
+    <p:sldMasterId xmlns:r="http://schemas.openxmlformats.org/officeDocument/2006/relationships" id="2147483648" r:id="Rd660ef99bde54fca"/>
   </p:sldMasterIdLst>
   <p:notesMasterIdLst>
-    <p:notesMasterId xmlns:r="http://schemas.openxmlformats.org/officeDocument/2006/relationships" r:id="R037c8194d7b44976"/>
+    <p:notesMasterId xmlns:r="http://schemas.openxmlformats.org/officeDocument/2006/relationships" r:id="Rb94fabae44144671"/>
   </p:notesMasterIdLst>
   <p:sldIdLst>
-    <p:sldId xmlns:r="http://schemas.openxmlformats.org/officeDocument/2006/relationships" id="256" r:id="R0f227fb191494a46"/>
-    <p:sldId xmlns:r="http://schemas.openxmlformats.org/officeDocument/2006/relationships" id="257" r:id="R70d35a503e174b9f"/>
-    <p:sldId xmlns:r="http://schemas.openxmlformats.org/officeDocument/2006/relationships" id="258" r:id="R9d0b14e333954491"/>
-    <p:sldId xmlns:r="http://schemas.openxmlformats.org/officeDocument/2006/relationships" id="259" r:id="Rd1498e6a4b544620"/>
-    <p:sldId xmlns:r="http://schemas.openxmlformats.org/officeDocument/2006/relationships" id="260" r:id="Rea85bcba66a94ce0"/>
-    <p:sldId xmlns:r="http://schemas.openxmlformats.org/officeDocument/2006/relationships" id="261" r:id="R26017eb4185b48a9"/>
-    <p:sldId xmlns:r="http://schemas.openxmlformats.org/officeDocument/2006/relationships" id="262" r:id="R3a99e520cc1a40a7"/>
-    <p:sldId xmlns:r="http://schemas.openxmlformats.org/officeDocument/2006/relationships" id="263" r:id="Rb5959dccf35a47d6"/>
-    <p:sldId xmlns:r="http://schemas.openxmlformats.org/officeDocument/2006/relationships" id="264" r:id="R1936cc9b8a0b4b68"/>
-    <p:sldId xmlns:r="http://schemas.openxmlformats.org/officeDocument/2006/relationships" id="265" r:id="Rf157bd6478094d82"/>
-    <p:sldId xmlns:r="http://schemas.openxmlformats.org/officeDocument/2006/relationships" id="266" r:id="Rab72790785484cb7"/>
-    <p:sldId xmlns:r="http://schemas.openxmlformats.org/officeDocument/2006/relationships" id="267" r:id="Rd3cd91d863274a8a"/>
-    <p:sldId xmlns:r="http://schemas.openxmlformats.org/officeDocument/2006/relationships" id="268" r:id="R1902708641454a2a"/>
+    <p:sldId xmlns:r="http://schemas.openxmlformats.org/officeDocument/2006/relationships" id="256" r:id="Rb46e27b1056b4db2"/>
+    <p:sldId xmlns:r="http://schemas.openxmlformats.org/officeDocument/2006/relationships" id="257" r:id="R54ceb35b105a41b0"/>
+    <p:sldId xmlns:r="http://schemas.openxmlformats.org/officeDocument/2006/relationships" id="258" r:id="R96f44dd2ebbe4b88"/>
+    <p:sldId xmlns:r="http://schemas.openxmlformats.org/officeDocument/2006/relationships" id="259" r:id="R71f8ad9dc67343e2"/>
+    <p:sldId xmlns:r="http://schemas.openxmlformats.org/officeDocument/2006/relationships" id="260" r:id="Rb0304b21622046b5"/>
+    <p:sldId xmlns:r="http://schemas.openxmlformats.org/officeDocument/2006/relationships" id="261" r:id="R60a820ae5f974028"/>
+    <p:sldId xmlns:r="http://schemas.openxmlformats.org/officeDocument/2006/relationships" id="262" r:id="R0cbfe1c9efb647a7"/>
+    <p:sldId xmlns:r="http://schemas.openxmlformats.org/officeDocument/2006/relationships" id="263" r:id="R0c35e62643684182"/>
+    <p:sldId xmlns:r="http://schemas.openxmlformats.org/officeDocument/2006/relationships" id="264" r:id="Rcc67911c70a449cb"/>
+    <p:sldId xmlns:r="http://schemas.openxmlformats.org/officeDocument/2006/relationships" id="265" r:id="R314fca8986e54f37"/>
+    <p:sldId xmlns:r="http://schemas.openxmlformats.org/officeDocument/2006/relationships" id="266" r:id="R594b90371e2e4af8"/>
+    <p:sldId xmlns:r="http://schemas.openxmlformats.org/officeDocument/2006/relationships" id="267" r:id="Rec29c6aa29fa4e02"/>
+    <p:sldId xmlns:r="http://schemas.openxmlformats.org/officeDocument/2006/relationships" id="268" r:id="Rce4f2cbaafa84e59"/>
   </p:sldIdLst>
   <p:sldSz cx="12192000" cy="6858000"/>
   <p:notesSz cx="6858000" cy="9144000"/>
@@ -991,7 +991,31 @@
           <a:lstStyle xmlns:a="http://schemas.openxmlformats.org/drawingml/2006/main"/>
           <a:p xmlns:a="http://schemas.openxmlformats.org/drawingml/2006/main">
             <a:r>
-              <a:t/>
+              <a:t>Secondary evidence only. These published cases are not interviews or pilots conducted by PROOF2PAY AI.</a:t>
+            </a:r>
+            <a:endParaRPr/>
+          </a:p>
+          <a:p xmlns:a="http://schemas.openxmlformats.org/drawingml/2006/main">
+            <a:r>
+              <a:t>PT Putra Bajubang/Pertamina Jambi thesis, UNAMA (2022): handwritten technician logs and repeated administration cross-checks. https://repository.unama.ac.id/2644/</a:t>
+            </a:r>
+            <a:endParaRPr/>
+          </a:p>
+          <a:p xmlns:a="http://schemas.openxmlformats.org/drawingml/2006/main">
+            <a:r>
+              <a:t>CV Pelangi Teknik study, Journal Speed (2021): WhatsApp orders, paper notes and receipts that can be misplaced. https://doi.org/10.55181/speed.v13i2.700</a:t>
+            </a:r>
+            <a:endParaRPr/>
+          </a:p>
+          <a:p xmlns:a="http://schemas.openxmlformats.org/drawingml/2006/main">
+            <a:r>
+              <a:t>CV Kurniatama thesis, UKDW (2016): customers received cost and parts information without detailed service information. https://repository.ukdw.ac.id/2774/</a:t>
+            </a:r>
+            <a:endParaRPr/>
+          </a:p>
+          <a:p xmlns:a="http://schemas.openxmlformats.org/drawingml/2006/main">
+            <a:r>
+              <a:t>Other workflow references: ServiceTitan official help and ServiceM8 official help. Product prevalence, Indonesian SME demand, time savings, and willingness to pay remain unvalidated.</a:t>
             </a:r>
             <a:endParaRPr/>
           </a:p>
@@ -1668,8 +1692,8 @@
   </p:cSld>
   <p:clrMap bg1="lt1" tx1="dk1" bg2="lt2" tx2="dk2" accent1="accent1" accent2="accent2" accent3="accent3" accent4="accent4" accent5="accent5" accent6="accent6" hlink="hlink" folHlink="folHlink"/>
   <p:sldLayoutIdLst>
-    <p:sldLayoutId xmlns:r="http://schemas.openxmlformats.org/officeDocument/2006/relationships" id="2147483649" r:id="Rcffedb5894854f78"/>
-    <p:sldLayoutId xmlns:r="http://schemas.openxmlformats.org/officeDocument/2006/relationships" id="2147483650" r:id="Rdbc3bdaa412c4bdf"/>
+    <p:sldLayoutId xmlns:r="http://schemas.openxmlformats.org/officeDocument/2006/relationships" id="2147483649" r:id="R38649fb83df6413f"/>
+    <p:sldLayoutId xmlns:r="http://schemas.openxmlformats.org/officeDocument/2006/relationships" id="2147483650" r:id="R4b156b04d4f54acd"/>
   </p:sldLayoutIdLst>
   <p:hf sldNum="0" hdr="0" ftr="0" dt="0"/>
   <p:txStyles>
@@ -9967,7 +9991,7 @@
         </p:spPr>
         <p:txBody>
           <a:bodyPr xmlns:a="http://schemas.openxmlformats.org/drawingml/2006/main" wrap="square" lIns="0" tIns="0" rIns="0" bIns="0" anchor="t">
-            <a:normAutofit/>
+            <a:normAutofit fontScale="100000"/>
           </a:bodyPr>
           <a:lstStyle xmlns:a="http://schemas.openxmlformats.org/drawingml/2006/main"/>
           <a:p xmlns:a="http://schemas.openxmlformats.org/drawingml/2006/main">
@@ -9983,7 +10007,7 @@
                 <a:ea typeface="Arial"/>
                 <a:cs typeface="Arial"/>
               </a:rPr>
-              <a:t>The workflow category is real. Product-market fit is not claimed yet.</a:t>
+              <a:t>Published evidence for the workflow problem</a:t>
             </a:r>
             <a:endParaRPr sz="2700"/>
           </a:p>
@@ -10015,7 +10039,7 @@
         </p:spPr>
         <p:txBody>
           <a:bodyPr xmlns:a="http://schemas.openxmlformats.org/drawingml/2006/main" wrap="square" lIns="0" tIns="0" rIns="0" bIns="0" anchor="t">
-            <a:normAutofit/>
+            <a:normAutofit fontScale="100000"/>
           </a:bodyPr>
           <a:lstStyle xmlns:a="http://schemas.openxmlformats.org/drawingml/2006/main"/>
           <a:p xmlns:a="http://schemas.openxmlformats.org/drawingml/2006/main">
@@ -10031,7 +10055,7 @@
                 <a:ea typeface="Arial"/>
                 <a:cs typeface="Arial"/>
               </a:rPr>
-              <a:t>Secondary research supports the completion-documentation / approval / invoicing handoff.</a:t>
+              <a:t>Indonesian AC-service cases document paper records and repeated manual checking.</a:t>
             </a:r>
             <a:endParaRPr sz="1200"/>
           </a:p>
@@ -10561,7 +10585,7 @@
         </p:spPr>
         <p:txBody>
           <a:bodyPr xmlns:a="http://schemas.openxmlformats.org/drawingml/2006/main" wrap="square" lIns="0" tIns="0" rIns="0" bIns="0" anchor="ctr">
-            <a:normAutofit/>
+            <a:normAutofit fontScale="100000"/>
           </a:bodyPr>
           <a:lstStyle xmlns:a="http://schemas.openxmlformats.org/drawingml/2006/main"/>
           <a:p xmlns:a="http://schemas.openxmlformats.org/drawingml/2006/main">
@@ -10577,7 +10601,7 @@
                 <a:ea typeface="Arial"/>
                 <a:cs typeface="Arial"/>
               </a:rPr>
-              <a:t>LOCAL CONTEXT</a:t>
+              <a:t>LOCAL STUDIES</a:t>
             </a:r>
             <a:endParaRPr sz="800"/>
           </a:p>
@@ -10609,7 +10633,7 @@
         </p:spPr>
         <p:txBody>
           <a:bodyPr xmlns:a="http://schemas.openxmlformats.org/drawingml/2006/main" wrap="square" lIns="0" tIns="0" rIns="0" bIns="0" anchor="ctr">
-            <a:normAutofit/>
+            <a:normAutofit fontScale="100000"/>
           </a:bodyPr>
           <a:lstStyle xmlns:a="http://schemas.openxmlformats.org/drawingml/2006/main"/>
           <a:p xmlns:a="http://schemas.openxmlformats.org/drawingml/2006/main">
@@ -10625,7 +10649,7 @@
                 <a:ea typeface="Arial"/>
                 <a:cs typeface="Arial"/>
               </a:rPr>
-              <a:t>Indonesia - BAST / SIPLah</a:t>
+              <a:t>Local AC service</a:t>
             </a:r>
             <a:endParaRPr sz="1300"/>
           </a:p>
@@ -10657,7 +10681,7 @@
         </p:spPr>
         <p:txBody>
           <a:bodyPr xmlns:a="http://schemas.openxmlformats.org/drawingml/2006/main" wrap="square" lIns="0" tIns="0" rIns="0" bIns="0" anchor="t">
-            <a:normAutofit/>
+            <a:normAutofit fontScale="100000"/>
           </a:bodyPr>
           <a:lstStyle xmlns:a="http://schemas.openxmlformats.org/drawingml/2006/main"/>
           <a:p xmlns:a="http://schemas.openxmlformats.org/drawingml/2006/main">
@@ -10673,7 +10697,7 @@
                 <a:ea typeface="Arial"/>
                 <a:cs typeface="Arial"/>
               </a:rPr>
-              <a:t>Official sources show formal handover evidence and payment sequencing in specific public-sector contexts.</a:t>
+              <a:t>Published cases report handwritten logs, misplaced receipts, and repeated administrative checks.</a:t>
             </a:r>
             <a:endParaRPr sz="1020"/>
           </a:p>
@@ -10788,7 +10812,7 @@
         </p:spPr>
         <p:txBody>
           <a:bodyPr xmlns:a="http://schemas.openxmlformats.org/drawingml/2006/main" wrap="square" lIns="0" tIns="0" rIns="0" bIns="0" anchor="t">
-            <a:normAutofit/>
+            <a:normAutofit fontScale="100000"/>
           </a:bodyPr>
           <a:lstStyle xmlns:a="http://schemas.openxmlformats.org/drawingml/2006/main"/>
           <a:p xmlns:a="http://schemas.openxmlformats.org/drawingml/2006/main">
@@ -10804,7 +10828,7 @@
                 <a:ea typeface="Arial"/>
                 <a:cs typeface="Arial"/>
               </a:rPr>
-              <a:t>Sources: ServiceTitan official help; ServiceM8 official help; JDIH Kementerian Keuangan; Rumah Pendidikan SIPLah. Accessed 27 Sep 2026.</a:t>
+              <a:t>Sources: ServiceTitan, ServiceM8, UNAMA, BSI and UKDW repositories. Accessed 28 Sep 2026.</a:t>
             </a:r>
             <a:endParaRPr sz="680"/>
           </a:p>
@@ -15184,7 +15208,7 @@
           <p:nvPr/>
         </p:nvPicPr>
         <p:blipFill>
-          <a:blip xmlns:r="http://schemas.openxmlformats.org/officeDocument/2006/relationships" xmlns:a="http://schemas.openxmlformats.org/drawingml/2006/main" r:embed="Rb076eb07c72d4ae6"/>
+          <a:blip xmlns:r="http://schemas.openxmlformats.org/officeDocument/2006/relationships" xmlns:a="http://schemas.openxmlformats.org/drawingml/2006/main" r:embed="R869fff39ad484a0e"/>
           <a:stretch xmlns:a="http://schemas.openxmlformats.org/drawingml/2006/main">
             <a:fillRect l="0" t="0" r="0" b="0"/>
           </a:stretch>

</xml_diff>